<commit_message>
Update presentations and notebooks
</commit_message>
<xml_diff>
--- a/Course content/Slides/Topic 8 - Clustering.pptx
+++ b/Course content/Slides/Topic 8 - Clustering.pptx
@@ -224,7 +224,7 @@
           <a:p>
             <a:fld id="{B9B1DC7F-8587-4047-9A5D-1FCB6614CAE0}" type="datetimeFigureOut">
               <a:rPr lang="en-US" smtClean="0"/>
-              <a:t>11/15/2022</a:t>
+              <a:t>11/16/2022</a:t>
             </a:fld>
             <a:endParaRPr lang="en-US"/>
           </a:p>
@@ -638,7 +638,7 @@
           <a:p>
             <a:fld id="{A7DB5662-7327-465C-9A70-AD96B7A8D67A}" type="datetimeFigureOut">
               <a:rPr lang="en-US" smtClean="0"/>
-              <a:t>11/15/2022</a:t>
+              <a:t>11/16/2022</a:t>
             </a:fld>
             <a:endParaRPr lang="en-US"/>
           </a:p>
@@ -836,7 +836,7 @@
           <a:p>
             <a:fld id="{A7DB5662-7327-465C-9A70-AD96B7A8D67A}" type="datetimeFigureOut">
               <a:rPr lang="en-US" smtClean="0"/>
-              <a:t>11/15/2022</a:t>
+              <a:t>11/16/2022</a:t>
             </a:fld>
             <a:endParaRPr lang="en-US"/>
           </a:p>
@@ -1044,7 +1044,7 @@
           <a:p>
             <a:fld id="{A7DB5662-7327-465C-9A70-AD96B7A8D67A}" type="datetimeFigureOut">
               <a:rPr lang="en-US" smtClean="0"/>
-              <a:t>11/15/2022</a:t>
+              <a:t>11/16/2022</a:t>
             </a:fld>
             <a:endParaRPr lang="en-US"/>
           </a:p>
@@ -1242,7 +1242,7 @@
           <a:p>
             <a:fld id="{A7DB5662-7327-465C-9A70-AD96B7A8D67A}" type="datetimeFigureOut">
               <a:rPr lang="en-US" smtClean="0"/>
-              <a:t>11/15/2022</a:t>
+              <a:t>11/16/2022</a:t>
             </a:fld>
             <a:endParaRPr lang="en-US"/>
           </a:p>
@@ -1517,7 +1517,7 @@
           <a:p>
             <a:fld id="{A7DB5662-7327-465C-9A70-AD96B7A8D67A}" type="datetimeFigureOut">
               <a:rPr lang="en-US" smtClean="0"/>
-              <a:t>11/15/2022</a:t>
+              <a:t>11/16/2022</a:t>
             </a:fld>
             <a:endParaRPr lang="en-US"/>
           </a:p>
@@ -1782,7 +1782,7 @@
           <a:p>
             <a:fld id="{A7DB5662-7327-465C-9A70-AD96B7A8D67A}" type="datetimeFigureOut">
               <a:rPr lang="en-US" smtClean="0"/>
-              <a:t>11/15/2022</a:t>
+              <a:t>11/16/2022</a:t>
             </a:fld>
             <a:endParaRPr lang="en-US"/>
           </a:p>
@@ -2194,7 +2194,7 @@
           <a:p>
             <a:fld id="{A7DB5662-7327-465C-9A70-AD96B7A8D67A}" type="datetimeFigureOut">
               <a:rPr lang="en-US" smtClean="0"/>
-              <a:t>11/15/2022</a:t>
+              <a:t>11/16/2022</a:t>
             </a:fld>
             <a:endParaRPr lang="en-US"/>
           </a:p>
@@ -2335,7 +2335,7 @@
           <a:p>
             <a:fld id="{A7DB5662-7327-465C-9A70-AD96B7A8D67A}" type="datetimeFigureOut">
               <a:rPr lang="en-US" smtClean="0"/>
-              <a:t>11/15/2022</a:t>
+              <a:t>11/16/2022</a:t>
             </a:fld>
             <a:endParaRPr lang="en-US"/>
           </a:p>
@@ -2448,7 +2448,7 @@
           <a:p>
             <a:fld id="{A7DB5662-7327-465C-9A70-AD96B7A8D67A}" type="datetimeFigureOut">
               <a:rPr lang="en-US" smtClean="0"/>
-              <a:t>11/15/2022</a:t>
+              <a:t>11/16/2022</a:t>
             </a:fld>
             <a:endParaRPr lang="en-US"/>
           </a:p>
@@ -2759,7 +2759,7 @@
           <a:p>
             <a:fld id="{A7DB5662-7327-465C-9A70-AD96B7A8D67A}" type="datetimeFigureOut">
               <a:rPr lang="en-US" smtClean="0"/>
-              <a:t>11/15/2022</a:t>
+              <a:t>11/16/2022</a:t>
             </a:fld>
             <a:endParaRPr lang="en-US"/>
           </a:p>
@@ -3047,7 +3047,7 @@
           <a:p>
             <a:fld id="{A7DB5662-7327-465C-9A70-AD96B7A8D67A}" type="datetimeFigureOut">
               <a:rPr lang="en-US" smtClean="0"/>
-              <a:t>11/15/2022</a:t>
+              <a:t>11/16/2022</a:t>
             </a:fld>
             <a:endParaRPr lang="en-US"/>
           </a:p>
@@ -3288,7 +3288,7 @@
           <a:p>
             <a:fld id="{A7DB5662-7327-465C-9A70-AD96B7A8D67A}" type="datetimeFigureOut">
               <a:rPr lang="en-US" smtClean="0"/>
-              <a:t>11/15/2022</a:t>
+              <a:t>11/16/2022</a:t>
             </a:fld>
             <a:endParaRPr lang="en-US"/>
           </a:p>
@@ -21692,8 +21692,8 @@
           </a:p>
         </p:txBody>
       </p:sp>
-      <mc:AlternateContent xmlns:mc="http://schemas.openxmlformats.org/markup-compatibility/2006">
-        <mc:Choice xmlns:a14="http://schemas.microsoft.com/office/drawing/2010/main" Requires="a14">
+      <mc:AlternateContent xmlns:mc="http://schemas.openxmlformats.org/markup-compatibility/2006" xmlns:a14="http://schemas.microsoft.com/office/drawing/2010/main">
+        <mc:Choice Requires="a14">
           <p:sp>
             <p:nvSpPr>
               <p:cNvPr id="3" name="Content Placeholder 2">
@@ -21977,7 +21977,7 @@
             </p:txBody>
           </p:sp>
         </mc:Choice>
-        <mc:Fallback>
+        <mc:Fallback xmlns="">
           <p:sp>
             <p:nvSpPr>
               <p:cNvPr id="3" name="Content Placeholder 2">
@@ -26971,7 +26971,7 @@
               <a:rPr lang="en-US" sz="2000" dirty="0">
                 <a:latin typeface="+mj-lt"/>
               </a:rPr>
-              <a:t>DBSCAN</a:t>
+              <a:t>DBSCAN: Defines clusters as continuous regions of high density. This is, if there are regions with no data, and other regions with a high concentration of data</a:t>
             </a:r>
           </a:p>
           <a:p>
@@ -26986,7 +26986,7 @@
               <a:rPr lang="en-US" sz="2000" dirty="0">
                 <a:latin typeface="+mj-lt"/>
               </a:rPr>
-              <a:t>BIRCH</a:t>
+              <a:t>BIRCH: Suitable for very large datasets with just a few features</a:t>
             </a:r>
           </a:p>
           <a:p>
@@ -27001,7 +27001,7 @@
               <a:rPr lang="en-US" sz="2000" dirty="0">
                 <a:latin typeface="+mj-lt"/>
               </a:rPr>
-              <a:t>Mean-shift</a:t>
+              <a:t>Mean-shift: Groups observations in circles of high density. Not suitable for large datasets</a:t>
             </a:r>
           </a:p>
           <a:p>
@@ -27016,7 +27016,7 @@
               <a:rPr lang="en-US" sz="2000" dirty="0">
                 <a:latin typeface="+mj-lt"/>
               </a:rPr>
-              <a:t>Affinity propagation</a:t>
+              <a:t>Affinity propagation: Uses a voting system. Not suitable for large datasets</a:t>
             </a:r>
           </a:p>
           <a:p>
@@ -27031,8 +27031,32 @@
               <a:rPr lang="en-US" sz="2000" dirty="0">
                 <a:latin typeface="+mj-lt"/>
               </a:rPr>
-              <a:t>Spectral clustering</a:t>
+              <a:t>Spectral clustering: Applies a dimensionality reduction and then applies another clustering algorithm to that space</a:t>
             </a:r>
+          </a:p>
+          <a:p>
+            <a:pPr>
+              <a:lnSpc>
+                <a:spcPct val="150000"/>
+              </a:lnSpc>
+              <a:buFont typeface="Wingdings" panose="05000000000000000000" pitchFamily="2" charset="2"/>
+              <a:buChar char="§"/>
+            </a:pPr>
+            <a:r>
+              <a:rPr lang="en-US" sz="2000" dirty="0">
+                <a:latin typeface="+mj-lt"/>
+              </a:rPr>
+              <a:t>Gaussian mixture: Appropriate for </a:t>
+            </a:r>
+            <a:r>
+              <a:rPr lang="en-US" sz="2000">
+                <a:latin typeface="+mj-lt"/>
+              </a:rPr>
+              <a:t>ellipsoidal clusters</a:t>
+            </a:r>
+            <a:endParaRPr lang="en-US" sz="2000" dirty="0">
+              <a:latin typeface="+mj-lt"/>
+            </a:endParaRPr>
           </a:p>
         </p:txBody>
       </p:sp>
@@ -28387,8 +28411,8 @@
           </a:p>
         </p:txBody>
       </p:sp>
-      <mc:AlternateContent xmlns:mc="http://schemas.openxmlformats.org/markup-compatibility/2006">
-        <mc:Choice xmlns:a14="http://schemas.microsoft.com/office/drawing/2010/main" Requires="a14">
+      <mc:AlternateContent xmlns:mc="http://schemas.openxmlformats.org/markup-compatibility/2006" xmlns:a14="http://schemas.microsoft.com/office/drawing/2010/main">
+        <mc:Choice Requires="a14">
           <p:sp>
             <p:nvSpPr>
               <p:cNvPr id="3" name="Content Placeholder 2">
@@ -28883,7 +28907,7 @@
             </p:txBody>
           </p:sp>
         </mc:Choice>
-        <mc:Fallback>
+        <mc:Fallback xmlns="">
           <p:sp>
             <p:nvSpPr>
               <p:cNvPr id="3" name="Content Placeholder 2">

</xml_diff>